<commit_message>
Fix slide 5 LLM count: bars and AI calls list now tie out to 7
Classification bar was 6/7; the actual LLM call sites in classify.py and
verify.py total 3 (single-story, batch-paste, bulk verify). The AI calls
list also lacked the batch-paste row. Both fixed so the slide is
self-consistent at 7 of 35.

Co-Authored-By: Claude Sonnet 4.6 <noreply@anthropic.com>
</commit_message>
<xml_diff>
--- a/static/WAF_Classifier_Capabilities.pptx
+++ b/static/WAF_Classifier_Capabilities.pptx
@@ -18114,7 +18114,7 @@
         <p:spPr>
           <a:xfrm>
             <a:off x="502920" y="1664208"/>
-            <a:ext cx="5394960" cy="658368"/>
+            <a:ext cx="5394960" cy="640080"/>
           </a:xfrm>
           <a:prstGeom prst="roundRect">
             <a:avLst>
@@ -18194,7 +18194,7 @@
         </p:nvSpPr>
         <p:spPr>
           <a:xfrm>
-            <a:off x="1115568" y="1719072"/>
+            <a:off x="1115568" y="1700784"/>
             <a:ext cx="3566160" cy="256032"/>
           </a:xfrm>
           <a:prstGeom prst="rect">
@@ -18210,7 +18210,7 @@
           <a:p>
             <a:pPr algn="l"/>
             <a:r>
-              <a:rPr sz="1100" b="1" i="0">
+              <a:rPr sz="1050" b="1" i="0">
                 <a:solidFill>
                   <a:srgbClr val="0F111A"/>
                 </a:solidFill>
@@ -18228,23 +18228,23 @@
         </p:nvSpPr>
         <p:spPr>
           <a:xfrm>
-            <a:off x="1115568" y="1993392"/>
-            <a:ext cx="3749039" cy="274320"/>
-          </a:xfrm>
-          <a:prstGeom prst="rect">
-            <a:avLst/>
-          </a:prstGeom>
-          <a:noFill/>
-        </p:spPr>
-        <p:txBody>
-          <a:bodyPr wrap="square">
-            <a:spAutoFit/>
-          </a:bodyPr>
-          <a:lstStyle/>
-          <a:p>
-            <a:pPr algn="l"/>
-            <a:r>
-              <a:rPr sz="950" b="0" i="0">
+            <a:off x="1115568" y="1956816"/>
+            <a:ext cx="3749039" cy="310896"/>
+          </a:xfrm>
+          <a:prstGeom prst="rect">
+            <a:avLst/>
+          </a:prstGeom>
+          <a:noFill/>
+        </p:spPr>
+        <p:txBody>
+          <a:bodyPr wrap="square">
+            <a:spAutoFit/>
+          </a:bodyPr>
+          <a:lstStyle/>
+          <a:p>
+            <a:pPr algn="l"/>
+            <a:r>
+              <a:rPr sz="900" b="0" i="0">
                 <a:solidFill>
                   <a:srgbClr val="6B7396"/>
                 </a:solidFill>
@@ -18343,8 +18343,8 @@
         </p:nvSpPr>
         <p:spPr>
           <a:xfrm>
-            <a:off x="502920" y="2414016"/>
-            <a:ext cx="5394960" cy="658368"/>
+            <a:off x="502920" y="2340864"/>
+            <a:ext cx="5394960" cy="640080"/>
           </a:xfrm>
           <a:prstGeom prst="roundRect">
             <a:avLst>
@@ -18390,7 +18390,7 @@
         </p:nvSpPr>
         <p:spPr>
           <a:xfrm>
-            <a:off x="658368" y="2505456"/>
+            <a:off x="658368" y="2432304"/>
             <a:ext cx="347472" cy="457200"/>
           </a:xfrm>
           <a:prstGeom prst="rect">
@@ -18411,7 +18411,7 @@
                   <a:srgbClr val="1E223A"/>
                 </a:solidFill>
               </a:rPr>
-              <a:t>📦</a:t>
+              <a:t>📋</a:t>
             </a:r>
           </a:p>
         </p:txBody>
@@ -18424,7 +18424,7 @@
         </p:nvSpPr>
         <p:spPr>
           <a:xfrm>
-            <a:off x="1115568" y="2468880"/>
+            <a:off x="1115568" y="2377440"/>
             <a:ext cx="3566160" cy="256032"/>
           </a:xfrm>
           <a:prstGeom prst="rect">
@@ -18440,12 +18440,12 @@
           <a:p>
             <a:pPr algn="l"/>
             <a:r>
-              <a:rPr sz="1100" b="1" i="0">
+              <a:rPr sz="1050" b="1" i="0">
                 <a:solidFill>
                   <a:srgbClr val="0F111A"/>
                 </a:solidFill>
               </a:rPr>
-              <a:t>Bulk file verification</a:t>
+              <a:t>Batch-paste classification</a:t>
             </a:r>
           </a:p>
         </p:txBody>
@@ -18458,28 +18458,28 @@
         </p:nvSpPr>
         <p:spPr>
           <a:xfrm>
-            <a:off x="1115568" y="2743200"/>
-            <a:ext cx="3749039" cy="274320"/>
-          </a:xfrm>
-          <a:prstGeom prst="rect">
-            <a:avLst/>
-          </a:prstGeom>
-          <a:noFill/>
-        </p:spPr>
-        <p:txBody>
-          <a:bodyPr wrap="square">
-            <a:spAutoFit/>
-          </a:bodyPr>
-          <a:lstStyle/>
-          <a:p>
-            <a:pPr algn="l"/>
-            <a:r>
-              <a:rPr sz="950" b="0" i="0">
+            <a:off x="1115568" y="2633472"/>
+            <a:ext cx="3749039" cy="310896"/>
+          </a:xfrm>
+          <a:prstGeom prst="rect">
+            <a:avLst/>
+          </a:prstGeom>
+          <a:noFill/>
+        </p:spPr>
+        <p:txBody>
+          <a:bodyPr wrap="square">
+            <a:spAutoFit/>
+          </a:bodyPr>
+          <a:lstStyle/>
+          <a:p>
+            <a:pPr algn="l"/>
+            <a:r>
+              <a:rPr sz="900" b="0" i="0">
                 <a:solidFill>
                   <a:srgbClr val="6B7396"/>
                 </a:solidFill>
               </a:rPr>
-              <a:t>Same classification at scale with concurrent workers</a:t>
+              <a:t>Classify several stories pasted into the chat at once</a:t>
             </a:r>
           </a:p>
         </p:txBody>
@@ -18492,7 +18492,7 @@
         </p:nvSpPr>
         <p:spPr>
           <a:xfrm>
-            <a:off x="5230368" y="2615184"/>
+            <a:off x="5230368" y="2542032"/>
             <a:ext cx="594360" cy="190500"/>
           </a:xfrm>
           <a:prstGeom prst="roundRect">
@@ -18539,7 +18539,7 @@
         </p:nvSpPr>
         <p:spPr>
           <a:xfrm>
-            <a:off x="5212080" y="2596896"/>
+            <a:off x="5212080" y="2523744"/>
             <a:ext cx="640080" cy="215900"/>
           </a:xfrm>
           <a:prstGeom prst="rect">
@@ -18573,8 +18573,8 @@
         </p:nvSpPr>
         <p:spPr>
           <a:xfrm>
-            <a:off x="502920" y="3163824"/>
-            <a:ext cx="5394960" cy="658368"/>
+            <a:off x="502920" y="3017520"/>
+            <a:ext cx="5394960" cy="640080"/>
           </a:xfrm>
           <a:prstGeom prst="roundRect">
             <a:avLst>
@@ -18620,7 +18620,7 @@
         </p:nvSpPr>
         <p:spPr>
           <a:xfrm>
-            <a:off x="658368" y="3255264"/>
+            <a:off x="658368" y="3108960"/>
             <a:ext cx="347472" cy="457200"/>
           </a:xfrm>
           <a:prstGeom prst="rect">
@@ -18641,7 +18641,7 @@
                   <a:srgbClr val="1E223A"/>
                 </a:solidFill>
               </a:rPr>
-              <a:t>📝</a:t>
+              <a:t>📦</a:t>
             </a:r>
           </a:p>
         </p:txBody>
@@ -18654,7 +18654,7 @@
         </p:nvSpPr>
         <p:spPr>
           <a:xfrm>
-            <a:off x="1115568" y="3218688"/>
+            <a:off x="1115568" y="3054096"/>
             <a:ext cx="3566160" cy="256032"/>
           </a:xfrm>
           <a:prstGeom prst="rect">
@@ -18670,12 +18670,12 @@
           <a:p>
             <a:pPr algn="l"/>
             <a:r>
-              <a:rPr sz="1100" b="1" i="0">
+              <a:rPr sz="1050" b="1" i="0">
                 <a:solidFill>
                   <a:srgbClr val="0F111A"/>
                 </a:solidFill>
               </a:rPr>
-              <a:t>Executive narrative</a:t>
+              <a:t>Bulk file verification</a:t>
             </a:r>
           </a:p>
         </p:txBody>
@@ -18688,28 +18688,28 @@
         </p:nvSpPr>
         <p:spPr>
           <a:xfrm>
-            <a:off x="1115568" y="3493008"/>
-            <a:ext cx="3749039" cy="274320"/>
-          </a:xfrm>
-          <a:prstGeom prst="rect">
-            <a:avLst/>
-          </a:prstGeom>
-          <a:noFill/>
-        </p:spPr>
-        <p:txBody>
-          <a:bodyPr wrap="square">
-            <a:spAutoFit/>
-          </a:bodyPr>
-          <a:lstStyle/>
-          <a:p>
-            <a:pPr algn="l"/>
-            <a:r>
-              <a:rPr sz="950" b="0" i="0">
+            <a:off x="1115568" y="3310128"/>
+            <a:ext cx="3749039" cy="310896"/>
+          </a:xfrm>
+          <a:prstGeom prst="rect">
+            <a:avLst/>
+          </a:prstGeom>
+          <a:noFill/>
+        </p:spPr>
+        <p:txBody>
+          <a:bodyPr wrap="square">
+            <a:spAutoFit/>
+          </a:bodyPr>
+          <a:lstStyle/>
+          <a:p>
+            <a:pPr algn="l"/>
+            <a:r>
+              <a:rPr sz="900" b="0" i="0">
                 <a:solidFill>
                   <a:srgbClr val="6B7396"/>
                 </a:solidFill>
               </a:rPr>
-              <a:t>AI-written paragraph summary of classification stats</a:t>
+              <a:t>Same classification at scale with concurrent workers</a:t>
             </a:r>
           </a:p>
         </p:txBody>
@@ -18722,7 +18722,7 @@
         </p:nvSpPr>
         <p:spPr>
           <a:xfrm>
-            <a:off x="5230368" y="3364992"/>
+            <a:off x="5230368" y="3218688"/>
             <a:ext cx="594360" cy="190500"/>
           </a:xfrm>
           <a:prstGeom prst="roundRect">
@@ -18769,7 +18769,7 @@
         </p:nvSpPr>
         <p:spPr>
           <a:xfrm>
-            <a:off x="5212080" y="3346704"/>
+            <a:off x="5212080" y="3200400"/>
             <a:ext cx="640080" cy="215900"/>
           </a:xfrm>
           <a:prstGeom prst="rect">
@@ -18803,8 +18803,8 @@
         </p:nvSpPr>
         <p:spPr>
           <a:xfrm>
-            <a:off x="502920" y="3913632"/>
-            <a:ext cx="5394960" cy="658368"/>
+            <a:off x="502920" y="3694176"/>
+            <a:ext cx="5394960" cy="640080"/>
           </a:xfrm>
           <a:prstGeom prst="roundRect">
             <a:avLst>
@@ -18850,7 +18850,7 @@
         </p:nvSpPr>
         <p:spPr>
           <a:xfrm>
-            <a:off x="658368" y="4005072"/>
+            <a:off x="658368" y="3785616"/>
             <a:ext cx="347472" cy="457200"/>
           </a:xfrm>
           <a:prstGeom prst="rect">
@@ -18871,7 +18871,7 @@
                   <a:srgbClr val="1E223A"/>
                 </a:solidFill>
               </a:rPr>
-              <a:t>🎯</a:t>
+              <a:t>📝</a:t>
             </a:r>
           </a:p>
         </p:txBody>
@@ -18884,7 +18884,7 @@
         </p:nvSpPr>
         <p:spPr>
           <a:xfrm>
-            <a:off x="1115568" y="3968496"/>
+            <a:off x="1115568" y="3730752"/>
             <a:ext cx="3566160" cy="256032"/>
           </a:xfrm>
           <a:prstGeom prst="rect">
@@ -18900,12 +18900,12 @@
           <a:p>
             <a:pPr algn="l"/>
             <a:r>
-              <a:rPr sz="1100" b="1" i="0">
+              <a:rPr sz="1050" b="1" i="0">
                 <a:solidFill>
                   <a:srgbClr val="0F111A"/>
                 </a:solidFill>
               </a:rPr>
-              <a:t>DoR scoring</a:t>
+              <a:t>Executive narrative</a:t>
             </a:r>
           </a:p>
         </p:txBody>
@@ -18918,28 +18918,28 @@
         </p:nvSpPr>
         <p:spPr>
           <a:xfrm>
-            <a:off x="1115568" y="4242816"/>
-            <a:ext cx="3749039" cy="274320"/>
-          </a:xfrm>
-          <a:prstGeom prst="rect">
-            <a:avLst/>
-          </a:prstGeom>
-          <a:noFill/>
-        </p:spPr>
-        <p:txBody>
-          <a:bodyPr wrap="square">
-            <a:spAutoFit/>
-          </a:bodyPr>
-          <a:lstStyle/>
-          <a:p>
-            <a:pPr algn="l"/>
-            <a:r>
-              <a:rPr sz="950" b="0" i="0">
+            <a:off x="1115568" y="3986784"/>
+            <a:ext cx="3749039" cy="310896"/>
+          </a:xfrm>
+          <a:prstGeom prst="rect">
+            <a:avLst/>
+          </a:prstGeom>
+          <a:noFill/>
+        </p:spPr>
+        <p:txBody>
+          <a:bodyPr wrap="square">
+            <a:spAutoFit/>
+          </a:bodyPr>
+          <a:lstStyle/>
+          <a:p>
+            <a:pPr algn="l"/>
+            <a:r>
+              <a:rPr sz="900" b="0" i="0">
                 <a:solidFill>
                   <a:srgbClr val="6B7396"/>
                 </a:solidFill>
               </a:rPr>
-              <a:t>9-criterion pass/fail scored per story</a:t>
+              <a:t>AI-written paragraph summary of classification stats</a:t>
             </a:r>
           </a:p>
         </p:txBody>
@@ -18952,7 +18952,7 @@
         </p:nvSpPr>
         <p:spPr>
           <a:xfrm>
-            <a:off x="5230368" y="4114800"/>
+            <a:off x="5230368" y="3895344"/>
             <a:ext cx="594360" cy="190500"/>
           </a:xfrm>
           <a:prstGeom prst="roundRect">
@@ -18999,7 +18999,7 @@
         </p:nvSpPr>
         <p:spPr>
           <a:xfrm>
-            <a:off x="5212080" y="4096512"/>
+            <a:off x="5212080" y="3877056"/>
             <a:ext cx="640080" cy="215900"/>
           </a:xfrm>
           <a:prstGeom prst="rect">
@@ -19033,8 +19033,8 @@
         </p:nvSpPr>
         <p:spPr>
           <a:xfrm>
-            <a:off x="502920" y="4663440"/>
-            <a:ext cx="5394960" cy="658368"/>
+            <a:off x="502920" y="4370832"/>
+            <a:ext cx="5394960" cy="640080"/>
           </a:xfrm>
           <a:prstGeom prst="roundRect">
             <a:avLst>
@@ -19080,7 +19080,7 @@
         </p:nvSpPr>
         <p:spPr>
           <a:xfrm>
-            <a:off x="658368" y="4754880"/>
+            <a:off x="658368" y="4462272"/>
             <a:ext cx="347472" cy="457200"/>
           </a:xfrm>
           <a:prstGeom prst="rect">
@@ -19101,7 +19101,7 @@
                   <a:srgbClr val="1E223A"/>
                 </a:solidFill>
               </a:rPr>
-              <a:t>💬</a:t>
+              <a:t>🎯</a:t>
             </a:r>
           </a:p>
         </p:txBody>
@@ -19114,7 +19114,7 @@
         </p:nvSpPr>
         <p:spPr>
           <a:xfrm>
-            <a:off x="1115568" y="4718304"/>
+            <a:off x="1115568" y="4407408"/>
             <a:ext cx="3566160" cy="256032"/>
           </a:xfrm>
           <a:prstGeom prst="rect">
@@ -19130,12 +19130,12 @@
           <a:p>
             <a:pPr algn="l"/>
             <a:r>
-              <a:rPr sz="1100" b="1" i="0">
+              <a:rPr sz="1050" b="1" i="0">
                 <a:solidFill>
                   <a:srgbClr val="0F111A"/>
                 </a:solidFill>
               </a:rPr>
-              <a:t>Story improvement chat</a:t>
+              <a:t>DoR scoring</a:t>
             </a:r>
           </a:p>
         </p:txBody>
@@ -19148,28 +19148,28 @@
         </p:nvSpPr>
         <p:spPr>
           <a:xfrm>
-            <a:off x="1115568" y="4992624"/>
-            <a:ext cx="3749039" cy="274320"/>
-          </a:xfrm>
-          <a:prstGeom prst="rect">
-            <a:avLst/>
-          </a:prstGeom>
-          <a:noFill/>
-        </p:spPr>
-        <p:txBody>
-          <a:bodyPr wrap="square">
-            <a:spAutoFit/>
-          </a:bodyPr>
-          <a:lstStyle/>
-          <a:p>
-            <a:pPr algn="l"/>
-            <a:r>
-              <a:rPr sz="950" b="0" i="0">
+            <a:off x="1115568" y="4663440"/>
+            <a:ext cx="3749039" cy="310896"/>
+          </a:xfrm>
+          <a:prstGeom prst="rect">
+            <a:avLst/>
+          </a:prstGeom>
+          <a:noFill/>
+        </p:spPr>
+        <p:txBody>
+          <a:bodyPr wrap="square">
+            <a:spAutoFit/>
+          </a:bodyPr>
+          <a:lstStyle/>
+          <a:p>
+            <a:pPr algn="l"/>
+            <a:r>
+              <a:rPr sz="900" b="0" i="0">
                 <a:solidFill>
                   <a:srgbClr val="6B7396"/>
                 </a:solidFill>
               </a:rPr>
-              <a:t>Targeted fix suggestions per failing criterion</a:t>
+              <a:t>9-criterion pass/fail scored per story</a:t>
             </a:r>
           </a:p>
         </p:txBody>
@@ -19182,7 +19182,7 @@
         </p:nvSpPr>
         <p:spPr>
           <a:xfrm>
-            <a:off x="5230368" y="4864608"/>
+            <a:off x="5230368" y="4572000"/>
             <a:ext cx="594360" cy="190500"/>
           </a:xfrm>
           <a:prstGeom prst="roundRect">
@@ -19229,7 +19229,7 @@
         </p:nvSpPr>
         <p:spPr>
           <a:xfrm>
-            <a:off x="5212080" y="4846320"/>
+            <a:off x="5212080" y="4553712"/>
             <a:ext cx="640080" cy="215900"/>
           </a:xfrm>
           <a:prstGeom prst="rect">
@@ -19263,8 +19263,8 @@
         </p:nvSpPr>
         <p:spPr>
           <a:xfrm>
-            <a:off x="502920" y="5413248"/>
-            <a:ext cx="5394960" cy="658368"/>
+            <a:off x="502920" y="5047488"/>
+            <a:ext cx="5394960" cy="640080"/>
           </a:xfrm>
           <a:prstGeom prst="roundRect">
             <a:avLst>
@@ -19310,7 +19310,7 @@
         </p:nvSpPr>
         <p:spPr>
           <a:xfrm>
-            <a:off x="658368" y="5504688"/>
+            <a:off x="658368" y="5138928"/>
             <a:ext cx="347472" cy="457200"/>
           </a:xfrm>
           <a:prstGeom prst="rect">
@@ -19331,7 +19331,7 @@
                   <a:srgbClr val="1E223A"/>
                 </a:solidFill>
               </a:rPr>
-              <a:t>✍️</a:t>
+              <a:t>💬</a:t>
             </a:r>
           </a:p>
         </p:txBody>
@@ -19344,7 +19344,7 @@
         </p:nvSpPr>
         <p:spPr>
           <a:xfrm>
-            <a:off x="1115568" y="5468112"/>
+            <a:off x="1115568" y="5084064"/>
             <a:ext cx="3566160" cy="256032"/>
           </a:xfrm>
           <a:prstGeom prst="rect">
@@ -19360,12 +19360,12 @@
           <a:p>
             <a:pPr algn="l"/>
             <a:r>
-              <a:rPr sz="1100" b="1" i="0">
+              <a:rPr sz="1050" b="1" i="0">
                 <a:solidFill>
                   <a:srgbClr val="0F111A"/>
                 </a:solidFill>
               </a:rPr>
-              <a:t>Story rewrite</a:t>
+              <a:t>Story improvement chat</a:t>
             </a:r>
           </a:p>
         </p:txBody>
@@ -19378,28 +19378,28 @@
         </p:nvSpPr>
         <p:spPr>
           <a:xfrm>
-            <a:off x="1115568" y="5742432"/>
-            <a:ext cx="3749039" cy="274320"/>
-          </a:xfrm>
-          <a:prstGeom prst="rect">
-            <a:avLst/>
-          </a:prstGeom>
-          <a:noFill/>
-        </p:spPr>
-        <p:txBody>
-          <a:bodyPr wrap="square">
-            <a:spAutoFit/>
-          </a:bodyPr>
-          <a:lstStyle/>
-          <a:p>
-            <a:pPr algn="l"/>
-            <a:r>
-              <a:rPr sz="950" b="0" i="0">
+            <a:off x="1115568" y="5340096"/>
+            <a:ext cx="3749039" cy="310896"/>
+          </a:xfrm>
+          <a:prstGeom prst="rect">
+            <a:avLst/>
+          </a:prstGeom>
+          <a:noFill/>
+        </p:spPr>
+        <p:txBody>
+          <a:bodyPr wrap="square">
+            <a:spAutoFit/>
+          </a:bodyPr>
+          <a:lstStyle/>
+          <a:p>
+            <a:pPr algn="l"/>
+            <a:r>
+              <a:rPr sz="900" b="0" i="0">
                 <a:solidFill>
                   <a:srgbClr val="6B7396"/>
                 </a:solidFill>
               </a:rPr>
-              <a:t>Full story rewrite addressing all failing criteria</a:t>
+              <a:t>Targeted fix suggestions per failing criterion</a:t>
             </a:r>
           </a:p>
         </p:txBody>
@@ -19412,7 +19412,7 @@
         </p:nvSpPr>
         <p:spPr>
           <a:xfrm>
-            <a:off x="5230368" y="5614416"/>
+            <a:off x="5230368" y="5248656"/>
             <a:ext cx="594360" cy="190500"/>
           </a:xfrm>
           <a:prstGeom prst="roundRect">
@@ -19459,7 +19459,7 @@
         </p:nvSpPr>
         <p:spPr>
           <a:xfrm>
-            <a:off x="5212080" y="5596128"/>
+            <a:off x="5212080" y="5230368"/>
             <a:ext cx="640080" cy="215900"/>
           </a:xfrm>
           <a:prstGeom prst="rect">
@@ -19487,7 +19487,237 @@
       </p:sp>
       <p:sp>
         <p:nvSpPr>
-          <p:cNvPr id="45" name="TextBox 44"/>
+          <p:cNvPr id="45" name="Rounded Rectangle 44"/>
+          <p:cNvSpPr/>
+          <p:nvPr/>
+        </p:nvSpPr>
+        <p:spPr>
+          <a:xfrm>
+            <a:off x="502920" y="5724144"/>
+            <a:ext cx="5394960" cy="640080"/>
+          </a:xfrm>
+          <a:prstGeom prst="roundRect">
+            <a:avLst>
+              <a:gd name="adj" fmla="val 4000"/>
+            </a:avLst>
+          </a:prstGeom>
+          <a:solidFill>
+            <a:srgbClr val="FFFFFF"/>
+          </a:solidFill>
+          <a:ln w="9525">
+            <a:solidFill>
+              <a:srgbClr val="D8DCEE"/>
+            </a:solidFill>
+          </a:ln>
+        </p:spPr>
+        <p:style>
+          <a:lnRef idx="1">
+            <a:schemeClr val="accent1"/>
+          </a:lnRef>
+          <a:fillRef idx="3">
+            <a:schemeClr val="accent1"/>
+          </a:fillRef>
+          <a:effectRef idx="2">
+            <a:schemeClr val="accent1"/>
+          </a:effectRef>
+          <a:fontRef idx="minor">
+            <a:schemeClr val="lt1"/>
+          </a:fontRef>
+        </p:style>
+        <p:txBody>
+          <a:bodyPr rtlCol="0" anchor="ctr"/>
+          <a:lstStyle/>
+          <a:p>
+            <a:pPr algn="ctr"/>
+          </a:p>
+        </p:txBody>
+      </p:sp>
+      <p:sp>
+        <p:nvSpPr>
+          <p:cNvPr id="46" name="TextBox 45"/>
+          <p:cNvSpPr txBox="1"/>
+          <p:nvPr/>
+        </p:nvSpPr>
+        <p:spPr>
+          <a:xfrm>
+            <a:off x="658368" y="5815584"/>
+            <a:ext cx="347472" cy="457200"/>
+          </a:xfrm>
+          <a:prstGeom prst="rect">
+            <a:avLst/>
+          </a:prstGeom>
+          <a:noFill/>
+        </p:spPr>
+        <p:txBody>
+          <a:bodyPr wrap="square">
+            <a:spAutoFit/>
+          </a:bodyPr>
+          <a:lstStyle/>
+          <a:p>
+            <a:pPr algn="l"/>
+            <a:r>
+              <a:rPr sz="1400" b="0" i="0">
+                <a:solidFill>
+                  <a:srgbClr val="1E223A"/>
+                </a:solidFill>
+              </a:rPr>
+              <a:t>✍️</a:t>
+            </a:r>
+          </a:p>
+        </p:txBody>
+      </p:sp>
+      <p:sp>
+        <p:nvSpPr>
+          <p:cNvPr id="47" name="TextBox 46"/>
+          <p:cNvSpPr txBox="1"/>
+          <p:nvPr/>
+        </p:nvSpPr>
+        <p:spPr>
+          <a:xfrm>
+            <a:off x="1115568" y="5760720"/>
+            <a:ext cx="3566160" cy="256032"/>
+          </a:xfrm>
+          <a:prstGeom prst="rect">
+            <a:avLst/>
+          </a:prstGeom>
+          <a:noFill/>
+        </p:spPr>
+        <p:txBody>
+          <a:bodyPr wrap="square">
+            <a:spAutoFit/>
+          </a:bodyPr>
+          <a:lstStyle/>
+          <a:p>
+            <a:pPr algn="l"/>
+            <a:r>
+              <a:rPr sz="1050" b="1" i="0">
+                <a:solidFill>
+                  <a:srgbClr val="0F111A"/>
+                </a:solidFill>
+              </a:rPr>
+              <a:t>Story rewrite</a:t>
+            </a:r>
+          </a:p>
+        </p:txBody>
+      </p:sp>
+      <p:sp>
+        <p:nvSpPr>
+          <p:cNvPr id="48" name="TextBox 47"/>
+          <p:cNvSpPr txBox="1"/>
+          <p:nvPr/>
+        </p:nvSpPr>
+        <p:spPr>
+          <a:xfrm>
+            <a:off x="1115568" y="6016752"/>
+            <a:ext cx="3749039" cy="310896"/>
+          </a:xfrm>
+          <a:prstGeom prst="rect">
+            <a:avLst/>
+          </a:prstGeom>
+          <a:noFill/>
+        </p:spPr>
+        <p:txBody>
+          <a:bodyPr wrap="square">
+            <a:spAutoFit/>
+          </a:bodyPr>
+          <a:lstStyle/>
+          <a:p>
+            <a:pPr algn="l"/>
+            <a:r>
+              <a:rPr sz="900" b="0" i="0">
+                <a:solidFill>
+                  <a:srgbClr val="6B7396"/>
+                </a:solidFill>
+              </a:rPr>
+              <a:t>Full story rewrite addressing all failing criteria</a:t>
+            </a:r>
+          </a:p>
+        </p:txBody>
+      </p:sp>
+      <p:sp>
+        <p:nvSpPr>
+          <p:cNvPr id="49" name="Rounded Rectangle 48"/>
+          <p:cNvSpPr/>
+          <p:nvPr/>
+        </p:nvSpPr>
+        <p:spPr>
+          <a:xfrm>
+            <a:off x="5230368" y="5925312"/>
+            <a:ext cx="594360" cy="190500"/>
+          </a:xfrm>
+          <a:prstGeom prst="roundRect">
+            <a:avLst>
+              <a:gd name="adj" fmla="val 4000"/>
+            </a:avLst>
+          </a:prstGeom>
+          <a:solidFill>
+            <a:srgbClr val="EDEBFF"/>
+          </a:solidFill>
+          <a:ln w="9525">
+            <a:solidFill>
+              <a:srgbClr val="EDEBFF"/>
+            </a:solidFill>
+          </a:ln>
+        </p:spPr>
+        <p:style>
+          <a:lnRef idx="1">
+            <a:schemeClr val="accent1"/>
+          </a:lnRef>
+          <a:fillRef idx="3">
+            <a:schemeClr val="accent1"/>
+          </a:fillRef>
+          <a:effectRef idx="2">
+            <a:schemeClr val="accent1"/>
+          </a:effectRef>
+          <a:fontRef idx="minor">
+            <a:schemeClr val="lt1"/>
+          </a:fontRef>
+        </p:style>
+        <p:txBody>
+          <a:bodyPr rtlCol="0" anchor="ctr"/>
+          <a:lstStyle/>
+          <a:p>
+            <a:pPr algn="ctr"/>
+          </a:p>
+        </p:txBody>
+      </p:sp>
+      <p:sp>
+        <p:nvSpPr>
+          <p:cNvPr id="50" name="TextBox 49"/>
+          <p:cNvSpPr txBox="1"/>
+          <p:nvPr/>
+        </p:nvSpPr>
+        <p:spPr>
+          <a:xfrm>
+            <a:off x="5212080" y="5907024"/>
+            <a:ext cx="640080" cy="215900"/>
+          </a:xfrm>
+          <a:prstGeom prst="rect">
+            <a:avLst/>
+          </a:prstGeom>
+          <a:noFill/>
+        </p:spPr>
+        <p:txBody>
+          <a:bodyPr wrap="square">
+            <a:spAutoFit/>
+          </a:bodyPr>
+          <a:lstStyle/>
+          <a:p>
+            <a:pPr algn="ctr"/>
+            <a:r>
+              <a:rPr sz="750" b="1" i="0">
+                <a:solidFill>
+                  <a:srgbClr val="4A40CC"/>
+                </a:solidFill>
+              </a:rPr>
+              <a:t>🤖 LLM</a:t>
+            </a:r>
+          </a:p>
+        </p:txBody>
+      </p:sp>
+      <p:sp>
+        <p:nvSpPr>
+          <p:cNvPr id="51" name="TextBox 50"/>
           <p:cNvSpPr txBox="1"/>
           <p:nvPr/>
         </p:nvSpPr>
@@ -19521,7 +19751,7 @@
       </p:sp>
       <p:sp>
         <p:nvSpPr>
-          <p:cNvPr id="46" name="TextBox 45"/>
+          <p:cNvPr id="52" name="TextBox 51"/>
           <p:cNvSpPr txBox="1"/>
           <p:nvPr/>
         </p:nvSpPr>
@@ -19555,7 +19785,7 @@
       </p:sp>
       <p:sp>
         <p:nvSpPr>
-          <p:cNvPr id="47" name="Rounded Rectangle 46"/>
+          <p:cNvPr id="53" name="Rounded Rectangle 52"/>
           <p:cNvSpPr/>
           <p:nvPr/>
         </p:nvSpPr>
@@ -19602,14 +19832,14 @@
       </p:sp>
       <p:sp>
         <p:nvSpPr>
-          <p:cNvPr id="48" name="Rounded Rectangle 47"/>
+          <p:cNvPr id="54" name="Rounded Rectangle 53"/>
           <p:cNvSpPr/>
           <p:nvPr/>
         </p:nvSpPr>
         <p:spPr>
           <a:xfrm>
             <a:off x="8065008" y="1737360"/>
-            <a:ext cx="2978331" cy="182880"/>
+            <a:ext cx="1489165" cy="182880"/>
           </a:xfrm>
           <a:prstGeom prst="roundRect">
             <a:avLst>
@@ -19647,7 +19877,7 @@
       </p:sp>
       <p:sp>
         <p:nvSpPr>
-          <p:cNvPr id="49" name="TextBox 48"/>
+          <p:cNvPr id="55" name="TextBox 54"/>
           <p:cNvSpPr txBox="1"/>
           <p:nvPr/>
         </p:nvSpPr>
@@ -19674,14 +19904,14 @@
                   <a:srgbClr val="5B52E8"/>
                 </a:solidFill>
               </a:rPr>
-              <a:t>6/7</a:t>
-            </a:r>
-          </a:p>
-        </p:txBody>
-      </p:sp>
-      <p:sp>
-        <p:nvSpPr>
-          <p:cNvPr id="50" name="TextBox 49"/>
+              <a:t>3/7</a:t>
+            </a:r>
+          </a:p>
+        </p:txBody>
+      </p:sp>
+      <p:sp>
+        <p:nvSpPr>
+          <p:cNvPr id="56" name="TextBox 55"/>
           <p:cNvSpPr txBox="1"/>
           <p:nvPr/>
         </p:nvSpPr>
@@ -19715,7 +19945,7 @@
       </p:sp>
       <p:sp>
         <p:nvSpPr>
-          <p:cNvPr id="51" name="Rounded Rectangle 50"/>
+          <p:cNvPr id="57" name="Rounded Rectangle 56"/>
           <p:cNvSpPr/>
           <p:nvPr/>
         </p:nvSpPr>
@@ -19762,7 +19992,7 @@
       </p:sp>
       <p:sp>
         <p:nvSpPr>
-          <p:cNvPr id="52" name="Rounded Rectangle 51"/>
+          <p:cNvPr id="58" name="Rounded Rectangle 57"/>
           <p:cNvSpPr/>
           <p:nvPr/>
         </p:nvSpPr>
@@ -19807,7 +20037,7 @@
       </p:sp>
       <p:sp>
         <p:nvSpPr>
-          <p:cNvPr id="53" name="TextBox 52"/>
+          <p:cNvPr id="59" name="TextBox 58"/>
           <p:cNvSpPr txBox="1"/>
           <p:nvPr/>
         </p:nvSpPr>
@@ -19841,7 +20071,7 @@
       </p:sp>
       <p:sp>
         <p:nvSpPr>
-          <p:cNvPr id="54" name="TextBox 53"/>
+          <p:cNvPr id="60" name="TextBox 59"/>
           <p:cNvSpPr txBox="1"/>
           <p:nvPr/>
         </p:nvSpPr>
@@ -19875,7 +20105,7 @@
       </p:sp>
       <p:sp>
         <p:nvSpPr>
-          <p:cNvPr id="55" name="Rounded Rectangle 54"/>
+          <p:cNvPr id="61" name="Rounded Rectangle 60"/>
           <p:cNvSpPr/>
           <p:nvPr/>
         </p:nvSpPr>
@@ -19922,7 +20152,7 @@
       </p:sp>
       <p:sp>
         <p:nvSpPr>
-          <p:cNvPr id="56" name="TextBox 55"/>
+          <p:cNvPr id="62" name="TextBox 61"/>
           <p:cNvSpPr txBox="1"/>
           <p:nvPr/>
         </p:nvSpPr>
@@ -19956,7 +20186,7 @@
       </p:sp>
       <p:sp>
         <p:nvSpPr>
-          <p:cNvPr id="57" name="TextBox 56"/>
+          <p:cNvPr id="63" name="TextBox 62"/>
           <p:cNvSpPr txBox="1"/>
           <p:nvPr/>
         </p:nvSpPr>
@@ -19990,7 +20220,7 @@
       </p:sp>
       <p:sp>
         <p:nvSpPr>
-          <p:cNvPr id="58" name="Rounded Rectangle 57"/>
+          <p:cNvPr id="64" name="Rounded Rectangle 63"/>
           <p:cNvSpPr/>
           <p:nvPr/>
         </p:nvSpPr>
@@ -20037,7 +20267,7 @@
       </p:sp>
       <p:sp>
         <p:nvSpPr>
-          <p:cNvPr id="59" name="TextBox 58"/>
+          <p:cNvPr id="65" name="TextBox 64"/>
           <p:cNvSpPr txBox="1"/>
           <p:nvPr/>
         </p:nvSpPr>
@@ -20071,7 +20301,7 @@
       </p:sp>
       <p:sp>
         <p:nvSpPr>
-          <p:cNvPr id="60" name="TextBox 59"/>
+          <p:cNvPr id="66" name="TextBox 65"/>
           <p:cNvSpPr txBox="1"/>
           <p:nvPr/>
         </p:nvSpPr>
@@ -20105,7 +20335,7 @@
       </p:sp>
       <p:sp>
         <p:nvSpPr>
-          <p:cNvPr id="61" name="Rounded Rectangle 60"/>
+          <p:cNvPr id="67" name="Rounded Rectangle 66"/>
           <p:cNvSpPr/>
           <p:nvPr/>
         </p:nvSpPr>
@@ -20152,7 +20382,7 @@
       </p:sp>
       <p:sp>
         <p:nvSpPr>
-          <p:cNvPr id="62" name="Rounded Rectangle 61"/>
+          <p:cNvPr id="68" name="Rounded Rectangle 67"/>
           <p:cNvSpPr/>
           <p:nvPr/>
         </p:nvSpPr>
@@ -20197,7 +20427,7 @@
       </p:sp>
       <p:sp>
         <p:nvSpPr>
-          <p:cNvPr id="63" name="TextBox 62"/>
+          <p:cNvPr id="69" name="TextBox 68"/>
           <p:cNvSpPr txBox="1"/>
           <p:nvPr/>
         </p:nvSpPr>
@@ -20231,7 +20461,7 @@
       </p:sp>
       <p:sp>
         <p:nvSpPr>
-          <p:cNvPr id="64" name="TextBox 63"/>
+          <p:cNvPr id="70" name="TextBox 69"/>
           <p:cNvSpPr txBox="1"/>
           <p:nvPr/>
         </p:nvSpPr>
@@ -20265,7 +20495,7 @@
       </p:sp>
       <p:sp>
         <p:nvSpPr>
-          <p:cNvPr id="65" name="Rounded Rectangle 64"/>
+          <p:cNvPr id="71" name="Rounded Rectangle 70"/>
           <p:cNvSpPr/>
           <p:nvPr/>
         </p:nvSpPr>
@@ -20312,7 +20542,7 @@
       </p:sp>
       <p:sp>
         <p:nvSpPr>
-          <p:cNvPr id="66" name="TextBox 65"/>
+          <p:cNvPr id="72" name="TextBox 71"/>
           <p:cNvSpPr txBox="1"/>
           <p:nvPr/>
         </p:nvSpPr>
@@ -20346,7 +20576,7 @@
       </p:sp>
       <p:sp>
         <p:nvSpPr>
-          <p:cNvPr id="67" name="TextBox 66"/>
+          <p:cNvPr id="73" name="TextBox 72"/>
           <p:cNvSpPr txBox="1"/>
           <p:nvPr/>
         </p:nvSpPr>
@@ -20380,7 +20610,7 @@
       </p:sp>
       <p:sp>
         <p:nvSpPr>
-          <p:cNvPr id="68" name="Rounded Rectangle 67"/>
+          <p:cNvPr id="74" name="Rounded Rectangle 73"/>
           <p:cNvSpPr/>
           <p:nvPr/>
         </p:nvSpPr>
@@ -20427,7 +20657,7 @@
       </p:sp>
       <p:sp>
         <p:nvSpPr>
-          <p:cNvPr id="69" name="TextBox 68"/>
+          <p:cNvPr id="75" name="TextBox 74"/>
           <p:cNvSpPr txBox="1"/>
           <p:nvPr/>
         </p:nvSpPr>
@@ -20461,7 +20691,7 @@
       </p:sp>
       <p:sp>
         <p:nvSpPr>
-          <p:cNvPr id="70" name="TextBox 69"/>
+          <p:cNvPr id="76" name="TextBox 75"/>
           <p:cNvSpPr txBox="1"/>
           <p:nvPr/>
         </p:nvSpPr>
@@ -20495,7 +20725,7 @@
       </p:sp>
       <p:sp>
         <p:nvSpPr>
-          <p:cNvPr id="71" name="Rounded Rectangle 70"/>
+          <p:cNvPr id="77" name="Rounded Rectangle 76"/>
           <p:cNvSpPr/>
           <p:nvPr/>
         </p:nvSpPr>
@@ -20542,7 +20772,7 @@
       </p:sp>
       <p:sp>
         <p:nvSpPr>
-          <p:cNvPr id="72" name="TextBox 71"/>
+          <p:cNvPr id="78" name="TextBox 77"/>
           <p:cNvSpPr txBox="1"/>
           <p:nvPr/>
         </p:nvSpPr>
@@ -20576,7 +20806,7 @@
       </p:sp>
       <p:sp>
         <p:nvSpPr>
-          <p:cNvPr id="73" name="Rounded Rectangle 72"/>
+          <p:cNvPr id="79" name="Rounded Rectangle 78"/>
           <p:cNvSpPr/>
           <p:nvPr/>
         </p:nvSpPr>
@@ -20623,7 +20853,7 @@
       </p:sp>
       <p:sp>
         <p:nvSpPr>
-          <p:cNvPr id="74" name="TextBox 73"/>
+          <p:cNvPr id="80" name="TextBox 79"/>
           <p:cNvSpPr txBox="1"/>
           <p:nvPr/>
         </p:nvSpPr>
@@ -20657,7 +20887,7 @@
       </p:sp>
       <p:sp>
         <p:nvSpPr>
-          <p:cNvPr id="75" name="Rounded Rectangle 74"/>
+          <p:cNvPr id="81" name="Rounded Rectangle 80"/>
           <p:cNvSpPr/>
           <p:nvPr/>
         </p:nvSpPr>
@@ -20704,7 +20934,7 @@
       </p:sp>
       <p:sp>
         <p:nvSpPr>
-          <p:cNvPr id="76" name="TextBox 75"/>
+          <p:cNvPr id="82" name="TextBox 81"/>
           <p:cNvSpPr txBox="1"/>
           <p:nvPr/>
         </p:nvSpPr>
@@ -20738,7 +20968,7 @@
       </p:sp>
       <p:sp>
         <p:nvSpPr>
-          <p:cNvPr id="77" name="Rounded Rectangle 76"/>
+          <p:cNvPr id="83" name="Rounded Rectangle 82"/>
           <p:cNvSpPr/>
           <p:nvPr/>
         </p:nvSpPr>
@@ -20785,7 +21015,7 @@
       </p:sp>
       <p:sp>
         <p:nvSpPr>
-          <p:cNvPr id="78" name="TextBox 77"/>
+          <p:cNvPr id="84" name="TextBox 83"/>
           <p:cNvSpPr txBox="1"/>
           <p:nvPr/>
         </p:nvSpPr>
@@ -20819,7 +21049,7 @@
       </p:sp>
       <p:sp>
         <p:nvSpPr>
-          <p:cNvPr id="79" name="Rounded Rectangle 78"/>
+          <p:cNvPr id="85" name="Rounded Rectangle 84"/>
           <p:cNvSpPr/>
           <p:nvPr/>
         </p:nvSpPr>
@@ -20866,7 +21096,7 @@
       </p:sp>
       <p:sp>
         <p:nvSpPr>
-          <p:cNvPr id="80" name="TextBox 79"/>
+          <p:cNvPr id="86" name="TextBox 85"/>
           <p:cNvSpPr txBox="1"/>
           <p:nvPr/>
         </p:nvSpPr>
@@ -20900,7 +21130,7 @@
       </p:sp>
       <p:sp>
         <p:nvSpPr>
-          <p:cNvPr id="81" name="Rounded Rectangle 80"/>
+          <p:cNvPr id="87" name="Rounded Rectangle 86"/>
           <p:cNvSpPr/>
           <p:nvPr/>
         </p:nvSpPr>
@@ -20947,7 +21177,7 @@
       </p:sp>
       <p:sp>
         <p:nvSpPr>
-          <p:cNvPr id="82" name="TextBox 81"/>
+          <p:cNvPr id="88" name="TextBox 87"/>
           <p:cNvSpPr txBox="1"/>
           <p:nvPr/>
         </p:nvSpPr>
@@ -20981,7 +21211,7 @@
       </p:sp>
       <p:sp>
         <p:nvSpPr>
-          <p:cNvPr id="83" name="Rectangle 82"/>
+          <p:cNvPr id="89" name="Rectangle 88"/>
           <p:cNvSpPr/>
           <p:nvPr/>
         </p:nvSpPr>
@@ -21026,7 +21256,7 @@
       </p:sp>
       <p:sp>
         <p:nvSpPr>
-          <p:cNvPr id="84" name="Rectangle 83"/>
+          <p:cNvPr id="90" name="Rectangle 89"/>
           <p:cNvSpPr/>
           <p:nvPr/>
         </p:nvSpPr>
@@ -21069,7 +21299,7 @@
       </p:sp>
       <p:sp>
         <p:nvSpPr>
-          <p:cNvPr id="85" name="TextBox 84"/>
+          <p:cNvPr id="91" name="TextBox 90"/>
           <p:cNvSpPr txBox="1"/>
           <p:nvPr/>
         </p:nvSpPr>
@@ -21103,7 +21333,7 @@
       </p:sp>
       <p:sp>
         <p:nvSpPr>
-          <p:cNvPr id="86" name="TextBox 85"/>
+          <p:cNvPr id="92" name="TextBox 91"/>
           <p:cNvSpPr txBox="1"/>
           <p:nvPr/>
         </p:nvSpPr>

</xml_diff>

<commit_message>
Reframe deck around in-PI course-correction; add pitchdeck prompt
Slide 2 (Problem) and slide 4 (What Leadership Gets) were too soft —
"are we aligned?" framing didn't name the actual cost. Sharpen to:
misclassification → human capital flows to the wrong priorities →
drift is invisible until quarter-end → leadership needs an in-PI
mechanism to redirect effort while the PI is still live.

- Slide 2: new title, quote, and 6 pain cards reframed around
  capital-misallocation and lack of course-correction lever.
- Slide 4: title now "What Leadership Gets — Course-Correct In-PI";
  closing line restated around redirecting capacity in days, not quarters.
- Add pitchdeck_prompt.md — reusable prompt template for generating
  similar leadership decks on other projects (5 main + appendix divider
  + N appendix structure, design system, copy rules, tie-out checklist).

Co-Authored-By: Claude Sonnet 4.6 <noreply@anthropic.com>
</commit_message>
<xml_diff>
--- a/static/WAF_Classifier_Capabilities.pptx
+++ b/static/WAF_Classifier_Capabilities.pptx
@@ -11958,7 +11958,7 @@
                   <a:srgbClr val="0F111A"/>
                 </a:solidFill>
               </a:rPr>
-              <a:t>We deliver thousands of stories every quarter.</a:t>
+              <a:t>Misclassification sends human capital to the wrong priorities.</a:t>
             </a:r>
           </a:p>
         </p:txBody>
@@ -11972,7 +11972,7 @@
         <p:spPr>
           <a:xfrm>
             <a:off x="502920" y="969264"/>
-            <a:ext cx="10515600" cy="457200"/>
+            <a:ext cx="10789920" cy="457200"/>
           </a:xfrm>
           <a:prstGeom prst="rect">
             <a:avLst/>
@@ -11992,7 +11992,7 @@
                   <a:srgbClr val="6B7396"/>
                 </a:solidFill>
               </a:rPr>
-              <a:t>But can we honestly say they're all aligned, accurately tracked, and tied to what matters most for the organisation?</a:t>
+              <a:t>And we don't see the drift until quarter-end — when the PI is already over. Misalignment must surface in-PI, while leadership can still redirect effort.</a:t>
             </a:r>
           </a:p>
         </p:txBody>
@@ -12116,7 +12116,7 @@
                   <a:srgbClr val="DC2626"/>
                 </a:solidFill>
               </a:rPr>
-              <a:t>❝  Are we working on the right things?  Are we aligned?  Are we focused on initiatives that drive real value?  ❞</a:t>
+              <a:t>❝  Every misclassified story is engineering capacity flowing to the wrong priority — and today, we don't catch it until it's too late to fix.  ❞</a:t>
             </a:r>
           </a:p>
         </p:txBody>
@@ -12274,7 +12274,7 @@
                   <a:srgbClr val="0F111A"/>
                 </a:solidFill>
               </a:rPr>
-              <a:t>Inconsistent classification</a:t>
+              <a:t>Misclassification at the source</a:t>
             </a:r>
           </a:p>
         </p:txBody>
@@ -12308,7 +12308,7 @@
                   <a:srgbClr val="6B7396"/>
                 </a:solidFill>
               </a:rPr>
-              <a:t>Hundreds of teams tag stories against the WAF independently. Without a shared baseline, the same story gets classified differently depending on who's doing the tagging.</a:t>
+              <a:t>Hundreds of teams tag stories independently. Without a shared baseline, the same kind of work lands in different WAF buckets across teams — distorting the picture from day one.</a:t>
             </a:r>
           </a:p>
         </p:txBody>
@@ -12432,7 +12432,7 @@
                   <a:srgbClr val="1E223A"/>
                 </a:solidFill>
               </a:rPr>
-              <a:t>⏱</a:t>
+              <a:t>⚖️</a:t>
             </a:r>
           </a:p>
         </p:txBody>
@@ -12466,7 +12466,7 @@
                   <a:srgbClr val="0F111A"/>
                 </a:solidFill>
               </a:rPr>
-              <a:t>Doesn't scale manually</a:t>
+              <a:t>Capital flows to the wrong priorities</a:t>
             </a:r>
           </a:p>
         </p:txBody>
@@ -12500,7 +12500,7 @@
                   <a:srgbClr val="6B7396"/>
                 </a:solidFill>
               </a:rPr>
-              <a:t>Reviewing and tagging thousands of stories per PI is slow, tedious, and error-prone. Central teams become a bottleneck. Deadlines get missed.</a:t>
+              <a:t>When tags are wrong, effort meant for strategic colours shows up as Run — or vice versa. Real allocation drifts from intent without anyone noticing.</a:t>
             </a:r>
           </a:p>
         </p:txBody>
@@ -12624,7 +12624,7 @@
                   <a:srgbClr val="1E223A"/>
                 </a:solidFill>
               </a:rPr>
-              <a:t>📋</a:t>
+              <a:t>⏱</a:t>
             </a:r>
           </a:p>
         </p:txBody>
@@ -12658,7 +12658,7 @@
                   <a:srgbClr val="0F111A"/>
                 </a:solidFill>
               </a:rPr>
-              <a:t>Poor story quality</a:t>
+              <a:t>Drift is invisible until quarter-end</a:t>
             </a:r>
           </a:p>
         </p:txBody>
@@ -12692,7 +12692,7 @@
                   <a:srgbClr val="6B7396"/>
                 </a:solidFill>
               </a:rPr>
-              <a:t>Stories missing acceptance criteria, source data, or clear outcomes can't be reliably classified — or delivered. Quality problems cascade.</a:t>
+              <a:t>By the time portfolio reports surface the misalignment, the PI is over. Leadership ends up reacting to last quarter's problem, not this one.</a:t>
             </a:r>
           </a:p>
         </p:txBody>
@@ -12816,7 +12816,7 @@
                   <a:srgbClr val="1E223A"/>
                 </a:solidFill>
               </a:rPr>
-              <a:t>🔍</a:t>
+              <a:t>🎯</a:t>
             </a:r>
           </a:p>
         </p:txBody>
@@ -12850,7 +12850,7 @@
                   <a:srgbClr val="0F111A"/>
                 </a:solidFill>
               </a:rPr>
-              <a:t>No audit trail</a:t>
+              <a:t>No in-PI course-correction lever</a:t>
             </a:r>
           </a:p>
         </p:txBody>
@@ -12884,7 +12884,7 @@
                   <a:srgbClr val="6B7396"/>
                 </a:solidFill>
               </a:rPr>
-              <a:t>When a classification is challenged — 'why is this tagged ORANGE?' — there's no record of the reasoning, who tagged it, or what version of the WAF was active.</a:t>
+              <a:t>Even when drift is suspected, there's no fast way to surface mismatched stories — no mechanism to redirect effort while the PI is still live.</a:t>
             </a:r>
           </a:p>
         </p:txBody>
@@ -13008,7 +13008,7 @@
                   <a:srgbClr val="1E223A"/>
                 </a:solidFill>
               </a:rPr>
-              <a:t>📊</a:t>
+              <a:t>🔍</a:t>
             </a:r>
           </a:p>
         </p:txBody>
@@ -13042,7 +13042,7 @@
                   <a:srgbClr val="0F111A"/>
                 </a:solidFill>
               </a:rPr>
-              <a:t>Leadership can't trust the data</a:t>
+              <a:t>No audit trail when tags are challenged</a:t>
             </a:r>
           </a:p>
         </p:txBody>
@@ -13076,7 +13076,7 @@
                   <a:srgbClr val="6B7396"/>
                 </a:solidFill>
               </a:rPr>
-              <a:t>If the Run vs. Change split or strategic category breakdown is based on inconsistent manual tagging, the numbers reported to senior leadership are unreliable.</a:t>
+              <a:t>When a classification is disputed — 'why is this tagged ORANGE?' — there's no record of who tagged it, the reasoning, or which WAF version was active.</a:t>
             </a:r>
           </a:p>
         </p:txBody>
@@ -13200,7 +13200,7 @@
                   <a:srgbClr val="1E223A"/>
                 </a:solidFill>
               </a:rPr>
-              <a:t>🎯</a:t>
+              <a:t>📊</a:t>
             </a:r>
           </a:p>
         </p:txBody>
@@ -13234,7 +13234,7 @@
                   <a:srgbClr val="0F111A"/>
                 </a:solidFill>
               </a:rPr>
-              <a:t>Misalignment goes undetected</a:t>
+              <a:t>Manual review doesn't scale</a:t>
             </a:r>
           </a:p>
         </p:txBody>
@@ -13268,7 +13268,7 @@
                   <a:srgbClr val="6B7396"/>
                 </a:solidFill>
               </a:rPr>
-              <a:t>Without visibility across teams and epics, work that drifts away from strategic priorities — SPEED, tech modernisation, customer value — goes unnoticed until it's too late.</a:t>
+              <a:t>Thousands of stories per PI, hundreds of teams. Central QA becomes the bottleneck — and gets skipped when deadlines hit.</a:t>
             </a:r>
           </a:p>
         </p:txBody>
@@ -15596,7 +15596,7 @@
                   <a:srgbClr val="0F111A"/>
                 </a:solidFill>
               </a:rPr>
-              <a:t>What Leadership Gets</a:t>
+              <a:t>What Leadership Gets — Course-Correct In-PI</a:t>
             </a:r>
           </a:p>
         </p:txBody>
@@ -15630,7 +15630,7 @@
                   <a:srgbClr val="6B7396"/>
                 </a:solidFill>
               </a:rPr>
-              <a:t>The decisions and visibility this platform enables — without dictating the work that produces them.</a:t>
+              <a:t>Surface misalignment in days, not quarters — so engineering capacity gets redirected while the PI is still live.</a:t>
             </a:r>
           </a:p>
         </p:txBody>
@@ -17661,7 +17661,7 @@
                   <a:srgbClr val="6B7396"/>
                 </a:solidFill>
               </a:rPr>
-              <a:t>WAF Classifier  ·  Built to bring consistency, auditability, and quality to every work item.</a:t>
+              <a:t>WAF Classifier  ·  Built to ensure engineering capacity flows to the right priorities — and surface drift fast enough to fix it.</a:t>
             </a:r>
           </a:p>
         </p:txBody>

</xml_diff>